<commit_message>
Deck and docs: two-model NPU cascade, RTMPose benchmarks
Co-Authored-By: Claude Opus 5.5 <noreply@anthropic.com>
</commit_message>
<xml_diff>
--- a/deck/PunarGati.pptx
+++ b/deck/PunarGati.pptx
@@ -144,7 +144,7 @@
                 </a:solidFill>
                 <a:latin typeface="Arial"/>
               </a:rPr>
-              <a:t>MoveNet latency on the Hexagon NPU (all layers on NPU)</a:t>
+              <a:t>w8a16 builds on the Hexagon NPU, all layers on the NPU</a:t>
             </a:r>
           </a:p>
         </c:rich>
@@ -168,7 +168,7 @@
               <c:strCache>
                 <c:ptCount val="1"/>
                 <c:pt idx="0">
-                  <c:v>MoveNet inference (ms)</c:v>
+                  <c:v>Inference (ms)</c:v>
                 </c:pt>
               </c:strCache>
             </c:strRef>
@@ -211,16 +211,16 @@
                 <c:ptCount val="4"/>
                 <c:lvl>
                   <c:pt idx="0">
-                    <c:v>X Elite · float</c:v>
+                    <c:v>MoveNet · X Elite</c:v>
                   </c:pt>
                   <c:pt idx="1">
-                    <c:v>X Elite · w8a16</c:v>
+                    <c:v>RTMPose · X Elite</c:v>
                   </c:pt>
                   <c:pt idx="2">
-                    <c:v>X2 Elite · float</c:v>
+                    <c:v>MoveNet · X2 Elite</c:v>
                   </c:pt>
                   <c:pt idx="3">
-                    <c:v>X2 Elite · w8a16</c:v>
+                    <c:v>RTMPose · X2 Elite</c:v>
                   </c:pt>
                 </c:lvl>
               </c:multiLvlStrCache>
@@ -233,16 +233,16 @@
                 <c:formatCode>General</c:formatCode>
                 <c:ptCount val="4"/>
                 <c:pt idx="0">
-                  <c:v>1.04</c:v>
+                  <c:v>1.054</c:v>
                 </c:pt>
                 <c:pt idx="1">
-                  <c:v>1.054</c:v>
+                  <c:v>1.836</c:v>
                 </c:pt>
                 <c:pt idx="2">
-                  <c:v>0.469</c:v>
+                  <c:v>0.44</c:v>
                 </c:pt>
                 <c:pt idx="3">
-                  <c:v>0.44</c:v>
+                  <c:v>0.785</c:v>
                 </c:pt>
               </c:numCache>
             </c:numRef>
@@ -323,7 +323,7 @@
         <c:axId val="2094734552"/>
         <c:scaling>
           <c:orientation val="minMax"/>
-          <c:max val="1.2"/>
+          <c:max val="2"/>
           <c:min val="0"/>
         </c:scaling>
         <c:delete val="0"/>
@@ -399,7 +399,7 @@
         <c:crossAx val="2094734554"/>
         <c:crosses val="autoZero"/>
         <c:crossBetween val="between"/>
-        <c:majorUnit val="0.2"/>
+        <c:majorUnit val="0.5"/>
       </c:valAx>
       <c:spPr>
         <a:noFill/>
@@ -4287,7 +4287,7 @@
                 <a:ea typeface="Aptos" pitchFamily="34" charset="-122"/>
                 <a:cs typeface="Aptos" pitchFamily="34" charset="-120"/>
               </a:rPr>
-              <a:t>Pose coach, 8 exercises, 5 tests, reports, local LLM, 7 languages</a:t>
+              <a:t>Two-model NPU pose cascade, 9 exercises, 5 tests, reports, local LLM, 7 languages</a:t>
             </a:r>
             <a:endParaRPr lang="en-US" sz="1400" dirty="0"/>
           </a:p>
@@ -4390,7 +4390,7 @@
                 <a:ea typeface="Aptos" pitchFamily="34" charset="-122"/>
                 <a:cs typeface="Aptos" pitchFamily="34" charset="-120"/>
               </a:rPr>
-              <a:t>RTMPose wholebody (AI Hub, 133 keypoints) for ankle, wrist and finger ROM</a:t>
+              <a:t>Hand-focused RTMPose crop for wrist and finger ROM (stroke and hand therapy)</a:t>
             </a:r>
             <a:endParaRPr lang="en-US" sz="1400" dirty="0"/>
           </a:p>
@@ -7297,7 +7297,7 @@
                 <a:ea typeface="Aptos" pitchFamily="34" charset="-122"/>
                 <a:cs typeface="Aptos" pitchFamily="34" charset="-120"/>
               </a:rPr>
-              <a:t>8 prescribed exercises. Reps per side, range of motion, tempo and a quality score for every rep. Spoken form corrections.</a:t>
+              <a:t>9 prescribed exercises. Reps per side, range of motion, tempo and a quality score for every rep. Spoken form corrections.</a:t>
             </a:r>
             <a:endParaRPr lang="en-US" sz="1450" dirty="0"/>
           </a:p>
@@ -12628,7 +12628,7 @@
                 <a:ea typeface="Aptos" pitchFamily="34" charset="-122"/>
                 <a:cs typeface="Aptos" pitchFamily="34" charset="-120"/>
               </a:rPr>
-              <a:t>Continuous vision runs on the Hexagon NPU in ~1 ms, about 3% of each frame</a:t>
+              <a:t>Two AI Hub pose models run on the Hexagon NPU in under 3 ms per frame</a:t>
             </a:r>
             <a:endParaRPr lang="en-US" sz="3000" dirty="0"/>
           </a:p>
@@ -12784,7 +12784,7 @@
                 <a:ea typeface="Aptos" pitchFamily="34" charset="-122"/>
                 <a:cs typeface="Aptos" pitchFamily="34" charset="-120"/>
               </a:rPr>
-              <a:t>Source: Qualcomm AI Hub device profiles, MoveNet v0.63.0 (ONNX). Budget at 30 fps: 33 ms per frame.</a:t>
+              <a:t>Source: Qualcomm AI Hub device profiles, v0.63.0 (ONNX). The cascade uses &lt;10% of the 33 ms frame budget at 30 fps.</a:t>
             </a:r>
             <a:endParaRPr lang="en-US" sz="1050" dirty="0"/>
           </a:p>
@@ -12857,7 +12857,7 @@
                 <a:ea typeface="Aptos" pitchFamily="34" charset="-122"/>
                 <a:cs typeface="Aptos" pitchFamily="34" charset="-120"/>
               </a:rPr>
-              <a:t>Always-on pose</a:t>
+              <a:t>Pose cascade</a:t>
             </a:r>
             <a:endParaRPr lang="en-US" sz="1400" dirty="0"/>
           </a:p>
@@ -12935,7 +12935,7 @@
                 <a:ea typeface="Aptos" pitchFamily="34" charset="-122"/>
                 <a:cs typeface="Aptos" pitchFamily="34" charset="-120"/>
               </a:rPr>
-              <a:t>onnxruntime-qnn plugin EP, HTP. Strict session proves 100% of ops on the NPU; context cache for instant relaunch</a:t>
+              <a:t>MoveNet tracks and RTMPose-WholeBody refines (133 keypoints, feet). onnxruntime-qnn, strict 100% offload, context cache</a:t>
             </a:r>
             <a:endParaRPr lang="en-US" sz="1200" dirty="0"/>
           </a:p>
@@ -13674,7 +13674,7 @@
                 <a:ea typeface="Aptos" pitchFamily="34" charset="-122"/>
                 <a:cs typeface="Aptos" pitchFamily="34" charset="-120"/>
               </a:rPr>
-              <a:t>Exact quantized I/O</a:t>
+              <a:t>Two-model NPU cascade</a:t>
             </a:r>
             <a:endParaRPr lang="en-US" sz="1700" dirty="0"/>
           </a:p>
@@ -13713,7 +13713,7 @@
                 <a:ea typeface="Aptos" pitchFamily="34" charset="-122"/>
                 <a:cs typeface="Aptos" pitchFamily="34" charset="-120"/>
               </a:rPr>
-              <a:t>The w8a16 AI Hub build uses uint16 tensors; scale and zero-point come from AI Hub's metadata.json.</a:t>
+              <a:t>MoveNet tracks the person. RTMPose-WholeBody re-estimates 133 keypoints on its box. Exact uint16 I/O from AI Hub metadata.</a:t>
             </a:r>
             <a:endParaRPr lang="en-US" sz="1350" dirty="0"/>
           </a:p>
@@ -13786,7 +13786,7 @@
                 <a:ea typeface="Aptos" pitchFamily="34" charset="-122"/>
                 <a:cs typeface="Aptos" pitchFamily="34" charset="-120"/>
               </a:rPr>
-              <a:t>Accuracy from 192 px</a:t>
+              <a:t>Accuracy from small models</a:t>
             </a:r>
             <a:endParaRPr lang="en-US" sz="1700" dirty="0"/>
           </a:p>
@@ -14010,7 +14010,7 @@
                 <a:ea typeface="Aptos" pitchFamily="34" charset="-122"/>
                 <a:cs typeface="Aptos" pitchFamily="34" charset="-120"/>
               </a:rPr>
-              <a:t>Robust clinical scores</a:t>
+              <a:t>View-independent tests</a:t>
             </a:r>
             <a:endParaRPr lang="en-US" sz="1700" dirty="0"/>
           </a:p>
@@ -14049,7 +14049,7 @@
                 <a:ea typeface="Aptos" pitchFamily="34" charset="-122"/>
                 <a:cs typeface="Aptos" pitchFamily="34" charset="-120"/>
               </a:rPr>
-              <a:t>Median-of-5 ROM, server-side test timelines, age/sex norms, flags instead of diagnoses.</a:t>
+              <a:t>Self-calibrating shoulder-height signal for sit/stand. 3/3 stands on the CDC's own front-view video.</a:t>
             </a:r>
             <a:endParaRPr lang="en-US" sz="1350" dirty="0"/>
           </a:p>
@@ -14161,7 +14161,7 @@
                 <a:ea typeface="Aptos" pitchFamily="34" charset="-122"/>
                 <a:cs typeface="Aptos" pitchFamily="34" charset="-120"/>
               </a:rPr>
-              <a:t>NPU → GPU → CPU ladder, rule/template fallbacks for the LLM, 27 tests incl. real-video regressions.</a:t>
+              <a:t>NPU → GPU → CPU ladder, a QNN 1.x fallback route, LLM-free fallbacks, 29 tests incl. real video.</a:t>
             </a:r>
             <a:endParaRPr lang="en-US" sz="1350" dirty="0"/>
           </a:p>

</xml_diff>

<commit_message>
Deck: animated demo GIF on the live-coaching slide; GIF starts on a rep
Co-Authored-By: Claude Opus 5.5 <noreply@anthropic.com>
</commit_message>
<xml_diff>
--- a/deck/PunarGati.pptx
+++ b/deck/PunarGati.pptx
@@ -8089,11 +8089,11 @@
         <p:spPr>
           <a:xfrm>
             <a:off x="548640" y="1691640"/>
-            <a:ext cx="7863840" cy="3264408"/>
+            <a:ext cx="7863840" cy="3090672"/>
           </a:xfrm>
           <a:prstGeom prst="roundRect">
             <a:avLst>
-              <a:gd name="adj" fmla="val 2241"/>
+              <a:gd name="adj" fmla="val 2367"/>
             </a:avLst>
           </a:prstGeom>
           <a:solidFill>
@@ -8116,7 +8116,7 @@
       </p:sp>
       <p:pic>
         <p:nvPicPr>
-          <p:cNvPr id="8" name="Image 0" descr="/Users/sachin/Development/snapdragon/punargati/deck/assets/coach_crop.png">    </p:cNvPr>
+          <p:cNvPr id="8" name="Image 0" descr="/Users/sachin/Development/snapdragon/punargati/deck/assets/demo.gif">    </p:cNvPr>
           <p:cNvPicPr>
             <a:picLocks noChangeAspect="1"/>
           </p:cNvPicPr>
@@ -8131,7 +8131,7 @@
         <p:spPr>
           <a:xfrm>
             <a:off x="621792" y="1764792"/>
-            <a:ext cx="7717536" cy="3163103"/>
+            <a:ext cx="7717536" cy="2942311"/>
           </a:xfrm>
           <a:prstGeom prst="rect">
             <a:avLst/>
@@ -14161,7 +14161,7 @@
                 <a:ea typeface="Aptos" pitchFamily="34" charset="-122"/>
                 <a:cs typeface="Aptos" pitchFamily="34" charset="-120"/>
               </a:rPr>
-              <a:t>NPU → GPU → CPU ladder, a QNN 1.x fallback route, LLM-free fallbacks, 29 tests incl. real video.</a:t>
+              <a:t>NPU → GPU → CPU ladder, a QNN 1.x fallback route, LLM-free fallbacks, 31 tests incl. real video.</a:t>
             </a:r>
             <a:endParaRPr lang="en-US" sz="1350" dirty="0"/>
           </a:p>

</xml_diff>

<commit_message>
Deck: CI-on-ARM64 note; rebuilt PDF and reel
Co-Authored-By: Claude Opus 5.5 <noreply@anthropic.com>
</commit_message>
<xml_diff>
--- a/deck/PunarGati.pptx
+++ b/deck/PunarGati.pptx
@@ -3499,7 +3499,46 @@
       </p:sp>
       <p:sp>
         <p:nvSpPr>
-          <p:cNvPr id="19" name="Shape 17"/>
+          <p:cNvPr id="19" name="Text 17"/>
+          <p:cNvSpPr/>
+          <p:nvPr/>
+        </p:nvSpPr>
+        <p:spPr>
+          <a:xfrm>
+            <a:off x="548640" y="5349240"/>
+            <a:ext cx="5852160" cy="548640"/>
+          </a:xfrm>
+          <a:prstGeom prst="rect">
+            <a:avLst/>
+          </a:prstGeom>
+          <a:noFill/>
+          <a:ln/>
+        </p:spPr>
+        <p:txBody>
+          <a:bodyPr wrap="square" rtlCol="0" anchor="ctr"/>
+          <a:lstStyle/>
+          <a:p>
+            <a:pPr indent="0" marL="0">
+              <a:buNone/>
+            </a:pPr>
+            <a:r>
+              <a:rPr lang="en-US" sz="1250" i="1" dirty="0">
+                <a:solidFill>
+                  <a:srgbClr val="0F766E"/>
+                </a:solidFill>
+                <a:latin typeface="Aptos" pitchFamily="34" charset="0"/>
+                <a:ea typeface="Aptos" pitchFamily="34" charset="-122"/>
+                <a:cs typeface="Aptos" pitchFamily="34" charset="-120"/>
+              </a:rPr>
+              <a:t>Tested on every push by CI on a native Windows-on-ARM64 runner: install script, QNN plugin + fallbacks, local-LLM scripts and all tests.</a:t>
+            </a:r>
+            <a:endParaRPr lang="en-US" sz="1250" dirty="0"/>
+          </a:p>
+        </p:txBody>
+      </p:sp>
+      <p:sp>
+        <p:nvSpPr>
+          <p:cNvPr id="20" name="Shape 18"/>
           <p:cNvSpPr/>
           <p:nvPr/>
         </p:nvSpPr>
@@ -3533,7 +3572,7 @@
       </p:sp>
       <p:sp>
         <p:nvSpPr>
-          <p:cNvPr id="20" name="Text 18"/>
+          <p:cNvPr id="21" name="Text 19"/>
           <p:cNvSpPr/>
           <p:nvPr/>
         </p:nvSpPr>
@@ -3572,7 +3611,7 @@
       </p:sp>
       <p:sp>
         <p:nvSpPr>
-          <p:cNvPr id="21" name="Shape 19"/>
+          <p:cNvPr id="22" name="Shape 20"/>
           <p:cNvSpPr/>
           <p:nvPr/>
         </p:nvSpPr>
@@ -3597,7 +3636,7 @@
       </p:sp>
       <p:sp>
         <p:nvSpPr>
-          <p:cNvPr id="22" name="Text 20"/>
+          <p:cNvPr id="23" name="Text 21"/>
           <p:cNvSpPr/>
           <p:nvPr/>
         </p:nvSpPr>
@@ -3636,7 +3675,7 @@
       </p:sp>
       <p:sp>
         <p:nvSpPr>
-          <p:cNvPr id="23" name="Shape 21"/>
+          <p:cNvPr id="24" name="Shape 22"/>
           <p:cNvSpPr/>
           <p:nvPr/>
         </p:nvSpPr>
@@ -3661,7 +3700,7 @@
       </p:sp>
       <p:sp>
         <p:nvSpPr>
-          <p:cNvPr id="24" name="Text 22"/>
+          <p:cNvPr id="25" name="Text 23"/>
           <p:cNvSpPr/>
           <p:nvPr/>
         </p:nvSpPr>
@@ -3700,7 +3739,7 @@
       </p:sp>
       <p:sp>
         <p:nvSpPr>
-          <p:cNvPr id="25" name="Shape 23"/>
+          <p:cNvPr id="26" name="Shape 24"/>
           <p:cNvSpPr/>
           <p:nvPr/>
         </p:nvSpPr>
@@ -3725,7 +3764,7 @@
       </p:sp>
       <p:sp>
         <p:nvSpPr>
-          <p:cNvPr id="26" name="Text 24"/>
+          <p:cNvPr id="27" name="Text 25"/>
           <p:cNvSpPr/>
           <p:nvPr/>
         </p:nvSpPr>
@@ -3764,7 +3803,7 @@
       </p:sp>
       <p:sp>
         <p:nvSpPr>
-          <p:cNvPr id="27" name="Shape 25"/>
+          <p:cNvPr id="28" name="Shape 26"/>
           <p:cNvSpPr/>
           <p:nvPr/>
         </p:nvSpPr>
@@ -3789,7 +3828,7 @@
       </p:sp>
       <p:sp>
         <p:nvSpPr>
-          <p:cNvPr id="28" name="Text 26"/>
+          <p:cNvPr id="29" name="Text 27"/>
           <p:cNvSpPr/>
           <p:nvPr/>
         </p:nvSpPr>
@@ -3828,7 +3867,7 @@
       </p:sp>
       <p:sp>
         <p:nvSpPr>
-          <p:cNvPr id="29" name="Shape 27"/>
+          <p:cNvPr id="30" name="Shape 28"/>
           <p:cNvSpPr/>
           <p:nvPr/>
         </p:nvSpPr>
@@ -3853,7 +3892,7 @@
       </p:sp>
       <p:sp>
         <p:nvSpPr>
-          <p:cNvPr id="30" name="Text 28"/>
+          <p:cNvPr id="31" name="Text 29"/>
           <p:cNvSpPr/>
           <p:nvPr/>
         </p:nvSpPr>
@@ -3892,7 +3931,7 @@
       </p:sp>
       <p:sp>
         <p:nvSpPr>
-          <p:cNvPr id="31" name="Shape 29"/>
+          <p:cNvPr id="32" name="Shape 30"/>
           <p:cNvSpPr/>
           <p:nvPr/>
         </p:nvSpPr>
@@ -3917,7 +3956,7 @@
       </p:sp>
       <p:sp>
         <p:nvSpPr>
-          <p:cNvPr id="32" name="Text 30"/>
+          <p:cNvPr id="33" name="Text 31"/>
           <p:cNvSpPr/>
           <p:nvPr/>
         </p:nvSpPr>

</xml_diff>